<commit_message>
deck: Marty Schoffstall co-author credit on both decks
</commit_message>
<xml_diff>
--- a/data/delphi_mechanisms.pptx
+++ b/data/delphi_mechanisms.pptx
@@ -3628,7 +3628,7 @@
           <a:lstStyle/>
           <a:p>
             <a:r>
-              <a:t>Delphi3080 vs DelphiCursor vs the MiroFish standard — mechanisms, targets, trade-offs</a:t>
+              <a:t>Delphi3080 vs DelphiCursor vs the MiroFish public service — mechanisms, targets, trade-offs  ·  Marty Schoffstall, co-author</a:t>
             </a:r>
           </a:p>
         </p:txBody>
@@ -3983,7 +3983,7 @@
           <a:lstStyle/>
           <a:p>
             <a:r>
-              <a:t>4 · Differences vs the MiroFish standard</a:t>
+              <a:t>4 · Differences vs the MiroFish public service</a:t>
             </a:r>
           </a:p>
         </p:txBody>
@@ -4048,7 +4048,7 @@
                     <a:lstStyle/>
                     <a:p>
                       <a:r>
-                        <a:t>MiroFish standard</a:t>
+                        <a:t>MiroFish public service</a:t>
                       </a:r>
                     </a:p>
                   </a:txBody>

</xml_diff>